<commit_message>
agregando detalle al pp
</commit_message>
<xml_diff>
--- a/Proyecto Zeus - Meteor.pptx
+++ b/Proyecto Zeus - Meteor.pptx
@@ -327,7 +327,8 @@
           <a:p>
             <a:fld id="{555B466B-AD3F-45F3-90D4-2662B9CB2B5C}" type="datetimeFigureOut">
               <a:rPr lang="es-AR" smtClean="0"/>
-              <a:t>22/06/2016</a:t>
+              <a:pPr/>
+              <a:t>14/07/2016</a:t>
             </a:fld>
             <a:endParaRPr lang="es-AR"/>
           </a:p>
@@ -391,6 +392,7 @@
           <a:p>
             <a:fld id="{685FA452-4338-48FE-B3D4-91F5EB6D3E85}" type="slidenum">
               <a:rPr lang="es-AR" smtClean="0"/>
+              <a:pPr/>
               <a:t>‹Nº›</a:t>
             </a:fld>
             <a:endParaRPr lang="es-AR"/>
@@ -514,7 +516,8 @@
           <a:p>
             <a:fld id="{555B466B-AD3F-45F3-90D4-2662B9CB2B5C}" type="datetimeFigureOut">
               <a:rPr lang="es-AR" smtClean="0"/>
-              <a:t>22/06/2016</a:t>
+              <a:pPr/>
+              <a:t>14/07/2016</a:t>
             </a:fld>
             <a:endParaRPr lang="es-AR"/>
           </a:p>
@@ -556,6 +559,7 @@
           <a:p>
             <a:fld id="{685FA452-4338-48FE-B3D4-91F5EB6D3E85}" type="slidenum">
               <a:rPr lang="es-AR" smtClean="0"/>
+              <a:pPr/>
               <a:t>‹Nº›</a:t>
             </a:fld>
             <a:endParaRPr lang="es-AR"/>
@@ -689,7 +693,8 @@
           <a:p>
             <a:fld id="{555B466B-AD3F-45F3-90D4-2662B9CB2B5C}" type="datetimeFigureOut">
               <a:rPr lang="es-AR" smtClean="0"/>
-              <a:t>22/06/2016</a:t>
+              <a:pPr/>
+              <a:t>14/07/2016</a:t>
             </a:fld>
             <a:endParaRPr lang="es-AR"/>
           </a:p>
@@ -731,6 +736,7 @@
           <a:p>
             <a:fld id="{685FA452-4338-48FE-B3D4-91F5EB6D3E85}" type="slidenum">
               <a:rPr lang="es-AR" smtClean="0"/>
+              <a:pPr/>
               <a:t>‹Nº›</a:t>
             </a:fld>
             <a:endParaRPr lang="es-AR"/>
@@ -869,7 +875,8 @@
           <a:p>
             <a:fld id="{555B466B-AD3F-45F3-90D4-2662B9CB2B5C}" type="datetimeFigureOut">
               <a:rPr lang="es-AR" smtClean="0"/>
-              <a:t>22/06/2016</a:t>
+              <a:pPr/>
+              <a:t>14/07/2016</a:t>
             </a:fld>
             <a:endParaRPr lang="es-AR"/>
           </a:p>
@@ -916,6 +923,7 @@
           <a:p>
             <a:fld id="{685FA452-4338-48FE-B3D4-91F5EB6D3E85}" type="slidenum">
               <a:rPr lang="es-AR" smtClean="0"/>
+              <a:pPr/>
               <a:t>‹Nº›</a:t>
             </a:fld>
             <a:endParaRPr lang="es-AR"/>
@@ -1116,7 +1124,8 @@
           <a:p>
             <a:fld id="{555B466B-AD3F-45F3-90D4-2662B9CB2B5C}" type="datetimeFigureOut">
               <a:rPr lang="es-AR" smtClean="0"/>
-              <a:t>22/06/2016</a:t>
+              <a:pPr/>
+              <a:t>14/07/2016</a:t>
             </a:fld>
             <a:endParaRPr lang="es-AR"/>
           </a:p>
@@ -1168,6 +1177,7 @@
           <a:p>
             <a:fld id="{685FA452-4338-48FE-B3D4-91F5EB6D3E85}" type="slidenum">
               <a:rPr lang="es-AR" smtClean="0"/>
+              <a:pPr/>
               <a:t>‹Nº›</a:t>
             </a:fld>
             <a:endParaRPr lang="es-AR"/>
@@ -1590,7 +1600,8 @@
           <a:p>
             <a:fld id="{555B466B-AD3F-45F3-90D4-2662B9CB2B5C}" type="datetimeFigureOut">
               <a:rPr lang="es-AR" smtClean="0"/>
-              <a:t>22/06/2016</a:t>
+              <a:pPr/>
+              <a:t>14/07/2016</a:t>
             </a:fld>
             <a:endParaRPr lang="es-AR"/>
           </a:p>
@@ -1642,6 +1653,7 @@
           <a:p>
             <a:fld id="{685FA452-4338-48FE-B3D4-91F5EB6D3E85}" type="slidenum">
               <a:rPr lang="es-AR" smtClean="0"/>
+              <a:pPr/>
               <a:t>‹Nº›</a:t>
             </a:fld>
             <a:endParaRPr lang="es-AR"/>
@@ -2005,7 +2017,8 @@
           <a:p>
             <a:fld id="{555B466B-AD3F-45F3-90D4-2662B9CB2B5C}" type="datetimeFigureOut">
               <a:rPr lang="es-AR" smtClean="0"/>
-              <a:t>22/06/2016</a:t>
+              <a:pPr/>
+              <a:t>14/07/2016</a:t>
             </a:fld>
             <a:endParaRPr lang="es-AR"/>
           </a:p>
@@ -2061,6 +2074,7 @@
           <a:p>
             <a:fld id="{685FA452-4338-48FE-B3D4-91F5EB6D3E85}" type="slidenum">
               <a:rPr lang="es-AR" smtClean="0"/>
+              <a:pPr/>
               <a:t>‹Nº›</a:t>
             </a:fld>
             <a:endParaRPr lang="es-AR"/>
@@ -2136,7 +2150,8 @@
           <a:p>
             <a:fld id="{555B466B-AD3F-45F3-90D4-2662B9CB2B5C}" type="datetimeFigureOut">
               <a:rPr lang="es-AR" smtClean="0"/>
-              <a:t>22/06/2016</a:t>
+              <a:pPr/>
+              <a:t>14/07/2016</a:t>
             </a:fld>
             <a:endParaRPr lang="es-AR"/>
           </a:p>
@@ -2178,6 +2193,7 @@
           <a:p>
             <a:fld id="{685FA452-4338-48FE-B3D4-91F5EB6D3E85}" type="slidenum">
               <a:rPr lang="es-AR" smtClean="0"/>
+              <a:pPr/>
               <a:t>‹Nº›</a:t>
             </a:fld>
             <a:endParaRPr lang="es-AR"/>
@@ -2231,7 +2247,8 @@
           <a:p>
             <a:fld id="{555B466B-AD3F-45F3-90D4-2662B9CB2B5C}" type="datetimeFigureOut">
               <a:rPr lang="es-AR" smtClean="0"/>
-              <a:t>22/06/2016</a:t>
+              <a:pPr/>
+              <a:t>14/07/2016</a:t>
             </a:fld>
             <a:endParaRPr lang="es-AR"/>
           </a:p>
@@ -2283,6 +2300,7 @@
           <a:p>
             <a:fld id="{685FA452-4338-48FE-B3D4-91F5EB6D3E85}" type="slidenum">
               <a:rPr lang="es-AR" smtClean="0"/>
+              <a:pPr/>
               <a:t>‹Nº›</a:t>
             </a:fld>
             <a:endParaRPr lang="es-AR"/>
@@ -2509,7 +2527,8 @@
           <a:p>
             <a:fld id="{555B466B-AD3F-45F3-90D4-2662B9CB2B5C}" type="datetimeFigureOut">
               <a:rPr lang="es-AR" smtClean="0"/>
-              <a:t>22/06/2016</a:t>
+              <a:pPr/>
+              <a:t>14/07/2016</a:t>
             </a:fld>
             <a:endParaRPr lang="es-AR"/>
           </a:p>
@@ -2569,6 +2588,7 @@
           <a:p>
             <a:fld id="{685FA452-4338-48FE-B3D4-91F5EB6D3E85}" type="slidenum">
               <a:rPr lang="es-AR" smtClean="0"/>
+              <a:pPr/>
               <a:t>‹Nº›</a:t>
             </a:fld>
             <a:endParaRPr lang="es-AR"/>
@@ -2761,7 +2781,8 @@
           <a:p>
             <a:fld id="{555B466B-AD3F-45F3-90D4-2662B9CB2B5C}" type="datetimeFigureOut">
               <a:rPr lang="es-AR" smtClean="0"/>
-              <a:t>22/06/2016</a:t>
+              <a:pPr/>
+              <a:t>14/07/2016</a:t>
             </a:fld>
             <a:endParaRPr lang="es-AR"/>
           </a:p>
@@ -2821,6 +2842,7 @@
           <a:p>
             <a:fld id="{685FA452-4338-48FE-B3D4-91F5EB6D3E85}" type="slidenum">
               <a:rPr lang="es-AR" smtClean="0"/>
+              <a:pPr/>
               <a:t>‹Nº›</a:t>
             </a:fld>
             <a:endParaRPr lang="es-AR"/>
@@ -3133,7 +3155,8 @@
           <a:p>
             <a:fld id="{555B466B-AD3F-45F3-90D4-2662B9CB2B5C}" type="datetimeFigureOut">
               <a:rPr lang="es-AR" smtClean="0"/>
-              <a:t>22/06/2016</a:t>
+              <a:pPr/>
+              <a:t>14/07/2016</a:t>
             </a:fld>
             <a:endParaRPr lang="es-AR"/>
           </a:p>
@@ -3207,6 +3230,7 @@
           <a:p>
             <a:fld id="{685FA452-4338-48FE-B3D4-91F5EB6D3E85}" type="slidenum">
               <a:rPr lang="es-AR" smtClean="0"/>
+              <a:pPr/>
               <a:t>‹Nº›</a:t>
             </a:fld>
             <a:endParaRPr lang="es-AR"/>
@@ -3665,7 +3689,7 @@
         </p:nvSpPr>
         <p:spPr>
           <a:xfrm>
-            <a:off x="1835696" y="2924944"/>
+            <a:off x="323528" y="2708920"/>
             <a:ext cx="1296144" cy="648072"/>
           </a:xfrm>
           <a:prstGeom prst="rect">
@@ -3695,7 +3719,7 @@
             <a:pPr algn="ctr"/>
             <a:r>
               <a:rPr lang="es-AR" dirty="0" smtClean="0"/>
-              <a:t>Cuenta</a:t>
+              <a:t>Cuentas</a:t>
             </a:r>
             <a:endParaRPr lang="es-AR" dirty="0"/>
           </a:p>
@@ -3709,7 +3733,7 @@
         </p:nvSpPr>
         <p:spPr>
           <a:xfrm>
-            <a:off x="1835696" y="1916832"/>
+            <a:off x="323528" y="1916832"/>
             <a:ext cx="1296144" cy="648072"/>
           </a:xfrm>
           <a:prstGeom prst="rect">
@@ -3753,7 +3777,7 @@
         </p:nvSpPr>
         <p:spPr>
           <a:xfrm>
-            <a:off x="1835696" y="3933056"/>
+            <a:off x="323528" y="3501008"/>
             <a:ext cx="1296144" cy="648072"/>
           </a:xfrm>
           <a:prstGeom prst="rect">
@@ -3783,7 +3807,7 @@
             <a:pPr algn="ctr"/>
             <a:r>
               <a:rPr lang="es-AR" dirty="0" smtClean="0"/>
-              <a:t>Contrato</a:t>
+              <a:t>Contratos</a:t>
             </a:r>
             <a:endParaRPr lang="es-AR" dirty="0"/>
           </a:p>
@@ -3797,7 +3821,7 @@
         </p:nvSpPr>
         <p:spPr>
           <a:xfrm>
-            <a:off x="3491880" y="3933056"/>
+            <a:off x="2843808" y="3573016"/>
             <a:ext cx="1296144" cy="648072"/>
           </a:xfrm>
           <a:prstGeom prst="rect">
@@ -3827,7 +3851,7 @@
             <a:pPr algn="ctr"/>
             <a:r>
               <a:rPr lang="es-AR" dirty="0" err="1" smtClean="0"/>
-              <a:t>Edesal</a:t>
+              <a:t>Edesals</a:t>
             </a:r>
             <a:endParaRPr lang="es-AR" dirty="0"/>
           </a:p>
@@ -3841,7 +3865,7 @@
         </p:nvSpPr>
         <p:spPr>
           <a:xfrm>
-            <a:off x="3491880" y="4941168"/>
+            <a:off x="4427984" y="5013176"/>
             <a:ext cx="1296144" cy="648072"/>
           </a:xfrm>
           <a:prstGeom prst="rect">
@@ -3885,7 +3909,7 @@
         </p:nvSpPr>
         <p:spPr>
           <a:xfrm>
-            <a:off x="5004048" y="4941168"/>
+            <a:off x="6012160" y="5013176"/>
             <a:ext cx="1296144" cy="648072"/>
           </a:xfrm>
           <a:prstGeom prst="rect">
@@ -3914,8 +3938,8 @@
           <a:p>
             <a:pPr algn="ctr"/>
             <a:r>
-              <a:rPr lang="es-AR" dirty="0" smtClean="0"/>
-              <a:t>Medidor</a:t>
+              <a:rPr lang="es-AR" dirty="0" err="1" smtClean="0"/>
+              <a:t>Medidors</a:t>
             </a:r>
             <a:endParaRPr lang="es-AR" dirty="0"/>
           </a:p>
@@ -3929,7 +3953,7 @@
         </p:nvSpPr>
         <p:spPr>
           <a:xfrm>
-            <a:off x="6588224" y="4941168"/>
+            <a:off x="7596336" y="5013176"/>
             <a:ext cx="1296144" cy="648072"/>
           </a:xfrm>
           <a:prstGeom prst="rect">
@@ -3973,7 +3997,7 @@
         </p:nvSpPr>
         <p:spPr>
           <a:xfrm>
-            <a:off x="5004048" y="3933056"/>
+            <a:off x="4427984" y="3573016"/>
             <a:ext cx="1296144" cy="648072"/>
           </a:xfrm>
           <a:prstGeom prst="rect">
@@ -4017,7 +4041,7 @@
         </p:nvSpPr>
         <p:spPr>
           <a:xfrm>
-            <a:off x="6588224" y="3933056"/>
+            <a:off x="6012160" y="3573016"/>
             <a:ext cx="1296144" cy="648072"/>
           </a:xfrm>
           <a:prstGeom prst="rect">
@@ -4053,6 +4077,677 @@
           </a:p>
         </p:txBody>
       </p:sp>
+      <p:sp>
+        <p:nvSpPr>
+          <p:cNvPr id="13" name="12 Rectángulo"/>
+          <p:cNvSpPr/>
+          <p:nvPr/>
+        </p:nvSpPr>
+        <p:spPr>
+          <a:xfrm>
+            <a:off x="4427984" y="2852936"/>
+            <a:ext cx="1296144" cy="648072"/>
+          </a:xfrm>
+          <a:prstGeom prst="rect">
+            <a:avLst/>
+          </a:prstGeom>
+        </p:spPr>
+        <p:style>
+          <a:lnRef idx="2">
+            <a:schemeClr val="accent1">
+              <a:shade val="50000"/>
+            </a:schemeClr>
+          </a:lnRef>
+          <a:fillRef idx="1">
+            <a:schemeClr val="accent1"/>
+          </a:fillRef>
+          <a:effectRef idx="0">
+            <a:schemeClr val="accent1"/>
+          </a:effectRef>
+          <a:fontRef idx="minor">
+            <a:schemeClr val="lt1"/>
+          </a:fontRef>
+        </p:style>
+        <p:txBody>
+          <a:bodyPr rtlCol="0" anchor="ctr"/>
+          <a:lstStyle/>
+          <a:p>
+            <a:pPr algn="ctr"/>
+            <a:r>
+              <a:rPr lang="es-AR" dirty="0" smtClean="0"/>
+              <a:t>Cargos </a:t>
+            </a:r>
+            <a:r>
+              <a:rPr lang="es-AR" dirty="0" err="1" smtClean="0"/>
+              <a:t>Add</a:t>
+            </a:r>
+            <a:endParaRPr lang="es-AR" dirty="0"/>
+          </a:p>
+        </p:txBody>
+      </p:sp>
+      <p:sp>
+        <p:nvSpPr>
+          <p:cNvPr id="14" name="13 Rectángulo"/>
+          <p:cNvSpPr/>
+          <p:nvPr/>
+        </p:nvSpPr>
+        <p:spPr>
+          <a:xfrm>
+            <a:off x="6012160" y="5733256"/>
+            <a:ext cx="1296144" cy="648072"/>
+          </a:xfrm>
+          <a:prstGeom prst="rect">
+            <a:avLst/>
+          </a:prstGeom>
+        </p:spPr>
+        <p:style>
+          <a:lnRef idx="2">
+            <a:schemeClr val="accent1">
+              <a:shade val="50000"/>
+            </a:schemeClr>
+          </a:lnRef>
+          <a:fillRef idx="1">
+            <a:schemeClr val="accent1"/>
+          </a:fillRef>
+          <a:effectRef idx="0">
+            <a:schemeClr val="accent1"/>
+          </a:effectRef>
+          <a:fontRef idx="minor">
+            <a:schemeClr val="lt1"/>
+          </a:fontRef>
+        </p:style>
+        <p:txBody>
+          <a:bodyPr rtlCol="0" anchor="ctr"/>
+          <a:lstStyle/>
+          <a:p>
+            <a:pPr algn="ctr"/>
+            <a:r>
+              <a:rPr lang="es-AR" dirty="0" smtClean="0"/>
+              <a:t>Os Trabajo</a:t>
+            </a:r>
+            <a:endParaRPr lang="es-AR" dirty="0"/>
+          </a:p>
+        </p:txBody>
+      </p:sp>
+      <p:sp>
+        <p:nvSpPr>
+          <p:cNvPr id="15" name="14 Rectángulo"/>
+          <p:cNvSpPr/>
+          <p:nvPr/>
+        </p:nvSpPr>
+        <p:spPr>
+          <a:xfrm>
+            <a:off x="4427984" y="2132856"/>
+            <a:ext cx="1296144" cy="648072"/>
+          </a:xfrm>
+          <a:prstGeom prst="rect">
+            <a:avLst/>
+          </a:prstGeom>
+        </p:spPr>
+        <p:style>
+          <a:lnRef idx="2">
+            <a:schemeClr val="accent1">
+              <a:shade val="50000"/>
+            </a:schemeClr>
+          </a:lnRef>
+          <a:fillRef idx="1">
+            <a:schemeClr val="accent1"/>
+          </a:fillRef>
+          <a:effectRef idx="0">
+            <a:schemeClr val="accent1"/>
+          </a:effectRef>
+          <a:fontRef idx="minor">
+            <a:schemeClr val="lt1"/>
+          </a:fontRef>
+        </p:style>
+        <p:txBody>
+          <a:bodyPr rtlCol="0" anchor="ctr"/>
+          <a:lstStyle/>
+          <a:p>
+            <a:pPr algn="ctr"/>
+            <a:r>
+              <a:rPr lang="es-AR" dirty="0" smtClean="0"/>
+              <a:t>Acuerdos</a:t>
+            </a:r>
+            <a:endParaRPr lang="es-AR" dirty="0"/>
+          </a:p>
+        </p:txBody>
+      </p:sp>
+      <p:sp>
+        <p:nvSpPr>
+          <p:cNvPr id="16" name="15 Rectángulo"/>
+          <p:cNvSpPr/>
+          <p:nvPr/>
+        </p:nvSpPr>
+        <p:spPr>
+          <a:xfrm>
+            <a:off x="4427984" y="4293096"/>
+            <a:ext cx="1296144" cy="648072"/>
+          </a:xfrm>
+          <a:prstGeom prst="rect">
+            <a:avLst/>
+          </a:prstGeom>
+        </p:spPr>
+        <p:style>
+          <a:lnRef idx="2">
+            <a:schemeClr val="accent1">
+              <a:shade val="50000"/>
+            </a:schemeClr>
+          </a:lnRef>
+          <a:fillRef idx="1">
+            <a:schemeClr val="accent1"/>
+          </a:fillRef>
+          <a:effectRef idx="0">
+            <a:schemeClr val="accent1"/>
+          </a:effectRef>
+          <a:fontRef idx="minor">
+            <a:schemeClr val="lt1"/>
+          </a:fontRef>
+        </p:style>
+        <p:txBody>
+          <a:bodyPr rtlCol="0" anchor="ctr"/>
+          <a:lstStyle/>
+          <a:p>
+            <a:pPr algn="ctr"/>
+            <a:r>
+              <a:rPr lang="es-AR" dirty="0" smtClean="0"/>
+              <a:t>Reclamos</a:t>
+            </a:r>
+            <a:endParaRPr lang="es-AR" dirty="0"/>
+          </a:p>
+        </p:txBody>
+      </p:sp>
+      <p:sp>
+        <p:nvSpPr>
+          <p:cNvPr id="17" name="16 Rectángulo"/>
+          <p:cNvSpPr/>
+          <p:nvPr/>
+        </p:nvSpPr>
+        <p:spPr>
+          <a:xfrm>
+            <a:off x="1907704" y="1916832"/>
+            <a:ext cx="1296144" cy="648072"/>
+          </a:xfrm>
+          <a:prstGeom prst="rect">
+            <a:avLst/>
+          </a:prstGeom>
+        </p:spPr>
+        <p:style>
+          <a:lnRef idx="2">
+            <a:schemeClr val="accent1">
+              <a:shade val="50000"/>
+            </a:schemeClr>
+          </a:lnRef>
+          <a:fillRef idx="1">
+            <a:schemeClr val="accent1"/>
+          </a:fillRef>
+          <a:effectRef idx="0">
+            <a:schemeClr val="accent1"/>
+          </a:effectRef>
+          <a:fontRef idx="minor">
+            <a:schemeClr val="lt1"/>
+          </a:fontRef>
+        </p:style>
+        <p:txBody>
+          <a:bodyPr rtlCol="0" anchor="ctr"/>
+          <a:lstStyle/>
+          <a:p>
+            <a:pPr algn="ctr"/>
+            <a:r>
+              <a:rPr lang="es-AR" dirty="0" smtClean="0"/>
+              <a:t>Historial</a:t>
+            </a:r>
+            <a:endParaRPr lang="es-AR" dirty="0"/>
+          </a:p>
+        </p:txBody>
+      </p:sp>
+      <p:cxnSp>
+        <p:nvCxnSpPr>
+          <p:cNvPr id="21" name="20 Conector angular"/>
+          <p:cNvCxnSpPr>
+            <a:stCxn id="7" idx="3"/>
+            <a:endCxn id="15" idx="1"/>
+          </p:cNvCxnSpPr>
+          <p:nvPr/>
+        </p:nvCxnSpPr>
+        <p:spPr>
+          <a:xfrm flipV="1">
+            <a:off x="4139952" y="2456892"/>
+            <a:ext cx="288032" cy="1440160"/>
+          </a:xfrm>
+          <a:prstGeom prst="bentConnector3">
+            <a:avLst>
+              <a:gd name="adj1" fmla="val 50000"/>
+            </a:avLst>
+          </a:prstGeom>
+        </p:spPr>
+        <p:style>
+          <a:lnRef idx="1">
+            <a:schemeClr val="accent1"/>
+          </a:lnRef>
+          <a:fillRef idx="0">
+            <a:schemeClr val="accent1"/>
+          </a:fillRef>
+          <a:effectRef idx="0">
+            <a:schemeClr val="accent1"/>
+          </a:effectRef>
+          <a:fontRef idx="minor">
+            <a:schemeClr val="tx1"/>
+          </a:fontRef>
+        </p:style>
+      </p:cxnSp>
+      <p:cxnSp>
+        <p:nvCxnSpPr>
+          <p:cNvPr id="23" name="22 Conector angular"/>
+          <p:cNvCxnSpPr>
+            <a:stCxn id="7" idx="3"/>
+            <a:endCxn id="13" idx="1"/>
+          </p:cNvCxnSpPr>
+          <p:nvPr/>
+        </p:nvCxnSpPr>
+        <p:spPr>
+          <a:xfrm flipV="1">
+            <a:off x="4139952" y="3176972"/>
+            <a:ext cx="288032" cy="720080"/>
+          </a:xfrm>
+          <a:prstGeom prst="bentConnector3">
+            <a:avLst>
+              <a:gd name="adj1" fmla="val 50000"/>
+            </a:avLst>
+          </a:prstGeom>
+        </p:spPr>
+        <p:style>
+          <a:lnRef idx="1">
+            <a:schemeClr val="accent1"/>
+          </a:lnRef>
+          <a:fillRef idx="0">
+            <a:schemeClr val="accent1"/>
+          </a:fillRef>
+          <a:effectRef idx="0">
+            <a:schemeClr val="accent1"/>
+          </a:effectRef>
+          <a:fontRef idx="minor">
+            <a:schemeClr val="tx1"/>
+          </a:fontRef>
+        </p:style>
+      </p:cxnSp>
+      <p:cxnSp>
+        <p:nvCxnSpPr>
+          <p:cNvPr id="25" name="24 Conector angular"/>
+          <p:cNvCxnSpPr>
+            <a:stCxn id="7" idx="3"/>
+            <a:endCxn id="11" idx="1"/>
+          </p:cNvCxnSpPr>
+          <p:nvPr/>
+        </p:nvCxnSpPr>
+        <p:spPr>
+          <a:xfrm>
+            <a:off x="4139952" y="3897052"/>
+            <a:ext cx="288032" cy="12700"/>
+          </a:xfrm>
+          <a:prstGeom prst="bentConnector3">
+            <a:avLst>
+              <a:gd name="adj1" fmla="val 50000"/>
+            </a:avLst>
+          </a:prstGeom>
+        </p:spPr>
+        <p:style>
+          <a:lnRef idx="1">
+            <a:schemeClr val="accent1"/>
+          </a:lnRef>
+          <a:fillRef idx="0">
+            <a:schemeClr val="accent1"/>
+          </a:fillRef>
+          <a:effectRef idx="0">
+            <a:schemeClr val="accent1"/>
+          </a:effectRef>
+          <a:fontRef idx="minor">
+            <a:schemeClr val="tx1"/>
+          </a:fontRef>
+        </p:style>
+      </p:cxnSp>
+      <p:cxnSp>
+        <p:nvCxnSpPr>
+          <p:cNvPr id="27" name="26 Conector angular"/>
+          <p:cNvCxnSpPr>
+            <a:stCxn id="7" idx="3"/>
+            <a:endCxn id="16" idx="1"/>
+          </p:cNvCxnSpPr>
+          <p:nvPr/>
+        </p:nvCxnSpPr>
+        <p:spPr>
+          <a:xfrm>
+            <a:off x="4139952" y="3897052"/>
+            <a:ext cx="288032" cy="720080"/>
+          </a:xfrm>
+          <a:prstGeom prst="bentConnector3">
+            <a:avLst>
+              <a:gd name="adj1" fmla="val 50000"/>
+            </a:avLst>
+          </a:prstGeom>
+        </p:spPr>
+        <p:style>
+          <a:lnRef idx="1">
+            <a:schemeClr val="accent1"/>
+          </a:lnRef>
+          <a:fillRef idx="0">
+            <a:schemeClr val="accent1"/>
+          </a:fillRef>
+          <a:effectRef idx="0">
+            <a:schemeClr val="accent1"/>
+          </a:effectRef>
+          <a:fontRef idx="minor">
+            <a:schemeClr val="tx1"/>
+          </a:fontRef>
+        </p:style>
+      </p:cxnSp>
+      <p:cxnSp>
+        <p:nvCxnSpPr>
+          <p:cNvPr id="29" name="28 Conector angular"/>
+          <p:cNvCxnSpPr>
+            <a:stCxn id="7" idx="3"/>
+            <a:endCxn id="8" idx="1"/>
+          </p:cNvCxnSpPr>
+          <p:nvPr/>
+        </p:nvCxnSpPr>
+        <p:spPr>
+          <a:xfrm>
+            <a:off x="4139952" y="3897052"/>
+            <a:ext cx="288032" cy="1440160"/>
+          </a:xfrm>
+          <a:prstGeom prst="bentConnector3">
+            <a:avLst>
+              <a:gd name="adj1" fmla="val 50000"/>
+            </a:avLst>
+          </a:prstGeom>
+        </p:spPr>
+        <p:style>
+          <a:lnRef idx="1">
+            <a:schemeClr val="accent1"/>
+          </a:lnRef>
+          <a:fillRef idx="0">
+            <a:schemeClr val="accent1"/>
+          </a:fillRef>
+          <a:effectRef idx="0">
+            <a:schemeClr val="accent1"/>
+          </a:effectRef>
+          <a:fontRef idx="minor">
+            <a:schemeClr val="tx1"/>
+          </a:fontRef>
+        </p:style>
+      </p:cxnSp>
+      <p:cxnSp>
+        <p:nvCxnSpPr>
+          <p:cNvPr id="31" name="30 Conector angular"/>
+          <p:cNvCxnSpPr>
+            <a:stCxn id="11" idx="3"/>
+            <a:endCxn id="12" idx="1"/>
+          </p:cNvCxnSpPr>
+          <p:nvPr/>
+        </p:nvCxnSpPr>
+        <p:spPr>
+          <a:xfrm>
+            <a:off x="5724128" y="3897052"/>
+            <a:ext cx="288032" cy="12700"/>
+          </a:xfrm>
+          <a:prstGeom prst="bentConnector3">
+            <a:avLst>
+              <a:gd name="adj1" fmla="val 50000"/>
+            </a:avLst>
+          </a:prstGeom>
+        </p:spPr>
+        <p:style>
+          <a:lnRef idx="1">
+            <a:schemeClr val="accent1"/>
+          </a:lnRef>
+          <a:fillRef idx="0">
+            <a:schemeClr val="accent1"/>
+          </a:fillRef>
+          <a:effectRef idx="0">
+            <a:schemeClr val="accent1"/>
+          </a:effectRef>
+          <a:fontRef idx="minor">
+            <a:schemeClr val="tx1"/>
+          </a:fontRef>
+        </p:style>
+      </p:cxnSp>
+      <p:cxnSp>
+        <p:nvCxnSpPr>
+          <p:cNvPr id="33" name="32 Conector angular"/>
+          <p:cNvCxnSpPr>
+            <a:stCxn id="8" idx="3"/>
+            <a:endCxn id="9" idx="1"/>
+          </p:cNvCxnSpPr>
+          <p:nvPr/>
+        </p:nvCxnSpPr>
+        <p:spPr>
+          <a:xfrm>
+            <a:off x="5724128" y="5337212"/>
+            <a:ext cx="288032" cy="12700"/>
+          </a:xfrm>
+          <a:prstGeom prst="bentConnector3">
+            <a:avLst>
+              <a:gd name="adj1" fmla="val 50000"/>
+            </a:avLst>
+          </a:prstGeom>
+        </p:spPr>
+        <p:style>
+          <a:lnRef idx="1">
+            <a:schemeClr val="accent1"/>
+          </a:lnRef>
+          <a:fillRef idx="0">
+            <a:schemeClr val="accent1"/>
+          </a:fillRef>
+          <a:effectRef idx="0">
+            <a:schemeClr val="accent1"/>
+          </a:effectRef>
+          <a:fontRef idx="minor">
+            <a:schemeClr val="tx1"/>
+          </a:fontRef>
+        </p:style>
+      </p:cxnSp>
+      <p:cxnSp>
+        <p:nvCxnSpPr>
+          <p:cNvPr id="35" name="34 Conector angular"/>
+          <p:cNvCxnSpPr>
+            <a:stCxn id="8" idx="3"/>
+            <a:endCxn id="14" idx="1"/>
+          </p:cNvCxnSpPr>
+          <p:nvPr/>
+        </p:nvCxnSpPr>
+        <p:spPr>
+          <a:xfrm>
+            <a:off x="5724128" y="5337212"/>
+            <a:ext cx="288032" cy="720080"/>
+          </a:xfrm>
+          <a:prstGeom prst="bentConnector3">
+            <a:avLst>
+              <a:gd name="adj1" fmla="val 50000"/>
+            </a:avLst>
+          </a:prstGeom>
+        </p:spPr>
+        <p:style>
+          <a:lnRef idx="1">
+            <a:schemeClr val="accent1"/>
+          </a:lnRef>
+          <a:fillRef idx="0">
+            <a:schemeClr val="accent1"/>
+          </a:fillRef>
+          <a:effectRef idx="0">
+            <a:schemeClr val="accent1"/>
+          </a:effectRef>
+          <a:fontRef idx="minor">
+            <a:schemeClr val="tx1"/>
+          </a:fontRef>
+        </p:style>
+      </p:cxnSp>
+      <p:cxnSp>
+        <p:nvCxnSpPr>
+          <p:cNvPr id="37" name="36 Conector angular"/>
+          <p:cNvCxnSpPr>
+            <a:stCxn id="9" idx="3"/>
+            <a:endCxn id="10" idx="1"/>
+          </p:cNvCxnSpPr>
+          <p:nvPr/>
+        </p:nvCxnSpPr>
+        <p:spPr>
+          <a:xfrm>
+            <a:off x="7308304" y="5337212"/>
+            <a:ext cx="288032" cy="12700"/>
+          </a:xfrm>
+          <a:prstGeom prst="bentConnector3">
+            <a:avLst>
+              <a:gd name="adj1" fmla="val 50000"/>
+            </a:avLst>
+          </a:prstGeom>
+        </p:spPr>
+        <p:style>
+          <a:lnRef idx="1">
+            <a:schemeClr val="accent1"/>
+          </a:lnRef>
+          <a:fillRef idx="0">
+            <a:schemeClr val="accent1"/>
+          </a:fillRef>
+          <a:effectRef idx="0">
+            <a:schemeClr val="accent1"/>
+          </a:effectRef>
+          <a:fontRef idx="minor">
+            <a:schemeClr val="tx1"/>
+          </a:fontRef>
+        </p:style>
+      </p:cxnSp>
+      <p:cxnSp>
+        <p:nvCxnSpPr>
+          <p:cNvPr id="39" name="38 Conector recto"/>
+          <p:cNvCxnSpPr>
+            <a:stCxn id="5" idx="2"/>
+            <a:endCxn id="4" idx="0"/>
+          </p:cNvCxnSpPr>
+          <p:nvPr/>
+        </p:nvCxnSpPr>
+        <p:spPr>
+          <a:xfrm>
+            <a:off x="971600" y="2564904"/>
+            <a:ext cx="0" cy="144016"/>
+          </a:xfrm>
+          <a:prstGeom prst="line">
+            <a:avLst/>
+          </a:prstGeom>
+        </p:spPr>
+        <p:style>
+          <a:lnRef idx="1">
+            <a:schemeClr val="accent1"/>
+          </a:lnRef>
+          <a:fillRef idx="0">
+            <a:schemeClr val="accent1"/>
+          </a:fillRef>
+          <a:effectRef idx="0">
+            <a:schemeClr val="accent1"/>
+          </a:effectRef>
+          <a:fontRef idx="minor">
+            <a:schemeClr val="tx1"/>
+          </a:fontRef>
+        </p:style>
+      </p:cxnSp>
+      <p:cxnSp>
+        <p:nvCxnSpPr>
+          <p:cNvPr id="41" name="40 Conector recto"/>
+          <p:cNvCxnSpPr>
+            <a:stCxn id="4" idx="2"/>
+            <a:endCxn id="6" idx="0"/>
+          </p:cNvCxnSpPr>
+          <p:nvPr/>
+        </p:nvCxnSpPr>
+        <p:spPr>
+          <a:xfrm>
+            <a:off x="971600" y="3356992"/>
+            <a:ext cx="0" cy="144016"/>
+          </a:xfrm>
+          <a:prstGeom prst="line">
+            <a:avLst/>
+          </a:prstGeom>
+        </p:spPr>
+        <p:style>
+          <a:lnRef idx="1">
+            <a:schemeClr val="accent1"/>
+          </a:lnRef>
+          <a:fillRef idx="0">
+            <a:schemeClr val="accent1"/>
+          </a:fillRef>
+          <a:effectRef idx="0">
+            <a:schemeClr val="accent1"/>
+          </a:effectRef>
+          <a:fontRef idx="minor">
+            <a:schemeClr val="tx1"/>
+          </a:fontRef>
+        </p:style>
+      </p:cxnSp>
+      <p:cxnSp>
+        <p:nvCxnSpPr>
+          <p:cNvPr id="43" name="42 Conector recto"/>
+          <p:cNvCxnSpPr>
+            <a:stCxn id="5" idx="3"/>
+            <a:endCxn id="17" idx="1"/>
+          </p:cNvCxnSpPr>
+          <p:nvPr/>
+        </p:nvCxnSpPr>
+        <p:spPr>
+          <a:xfrm>
+            <a:off x="1619672" y="2240868"/>
+            <a:ext cx="288032" cy="0"/>
+          </a:xfrm>
+          <a:prstGeom prst="line">
+            <a:avLst/>
+          </a:prstGeom>
+        </p:spPr>
+        <p:style>
+          <a:lnRef idx="1">
+            <a:schemeClr val="accent1"/>
+          </a:lnRef>
+          <a:fillRef idx="0">
+            <a:schemeClr val="accent1"/>
+          </a:fillRef>
+          <a:effectRef idx="0">
+            <a:schemeClr val="accent1"/>
+          </a:effectRef>
+          <a:fontRef idx="minor">
+            <a:schemeClr val="tx1"/>
+          </a:fontRef>
+        </p:style>
+      </p:cxnSp>
+      <p:cxnSp>
+        <p:nvCxnSpPr>
+          <p:cNvPr id="45" name="44 Conector recto"/>
+          <p:cNvCxnSpPr>
+            <a:stCxn id="6" idx="3"/>
+            <a:endCxn id="7" idx="1"/>
+          </p:cNvCxnSpPr>
+          <p:nvPr/>
+        </p:nvCxnSpPr>
+        <p:spPr>
+          <a:xfrm>
+            <a:off x="1619672" y="3825044"/>
+            <a:ext cx="1224136" cy="72008"/>
+          </a:xfrm>
+          <a:prstGeom prst="line">
+            <a:avLst/>
+          </a:prstGeom>
+        </p:spPr>
+        <p:style>
+          <a:lnRef idx="1">
+            <a:schemeClr val="accent1"/>
+          </a:lnRef>
+          <a:fillRef idx="0">
+            <a:schemeClr val="accent1"/>
+          </a:fillRef>
+          <a:effectRef idx="0">
+            <a:schemeClr val="accent1"/>
+          </a:effectRef>
+          <a:fontRef idx="minor">
+            <a:schemeClr val="tx1"/>
+          </a:fontRef>
+        </p:style>
+      </p:cxnSp>
     </p:spTree>
   </p:cSld>
   <p:clrMapOvr>

</xml_diff>

<commit_message>
implementando un tree html
</commit_message>
<xml_diff>
--- a/Proyecto Zeus - Meteor.pptx
+++ b/Proyecto Zeus - Meteor.pptx
@@ -105,6 +105,22 @@
       </a:defRPr>
     </a:lvl9pPr>
   </p:defaultTextStyle>
+  <p:extLst>
+    <p:ext uri="{EFAFB233-063F-42B5-8137-9DF3F51BA10A}">
+      <p15:sldGuideLst xmlns:p15="http://schemas.microsoft.com/office/powerpoint/2012/main">
+        <p15:guide id="1" orient="horz" pos="2160">
+          <p15:clr>
+            <a:srgbClr val="A4A3A4"/>
+          </p15:clr>
+        </p15:guide>
+        <p15:guide id="2" pos="2880">
+          <p15:clr>
+            <a:srgbClr val="A4A3A4"/>
+          </p15:clr>
+        </p15:guide>
+      </p15:sldGuideLst>
+    </p:ext>
+  </p:extLst>
 </p:presentation>
 </file>
 
@@ -223,7 +239,7 @@
           </a:lstStyle>
           <a:p>
             <a:r>
-              <a:rPr kumimoji="0" lang="es-ES" smtClean="0"/>
+              <a:rPr kumimoji="0" lang="es-ES"/>
               <a:t>Haga clic para modificar el estilo de título del patrón</a:t>
             </a:r>
             <a:endParaRPr kumimoji="0" lang="en-US"/>
@@ -294,7 +310,7 @@
           </a:lstStyle>
           <a:p>
             <a:r>
-              <a:rPr kumimoji="0" lang="es-ES" smtClean="0"/>
+              <a:rPr kumimoji="0" lang="es-ES"/>
               <a:t>Haga clic para modificar el estilo de subtítulo del patrón</a:t>
             </a:r>
             <a:endParaRPr kumimoji="0" lang="en-US"/>
@@ -328,7 +344,7 @@
             <a:fld id="{555B466B-AD3F-45F3-90D4-2662B9CB2B5C}" type="datetimeFigureOut">
               <a:rPr lang="es-AR" smtClean="0"/>
               <a:pPr/>
-              <a:t>14/07/2016</a:t>
+              <a:t>17/7/2016</a:t>
             </a:fld>
             <a:endParaRPr lang="es-AR"/>
           </a:p>
@@ -393,7 +409,7 @@
             <a:fld id="{685FA452-4338-48FE-B3D4-91F5EB6D3E85}" type="slidenum">
               <a:rPr lang="es-AR" smtClean="0"/>
               <a:pPr/>
-              <a:t>‹Nº›</a:t>
+              <a:t>‹#›</a:t>
             </a:fld>
             <a:endParaRPr lang="es-AR"/>
           </a:p>
@@ -440,7 +456,7 @@
           <a:lstStyle/>
           <a:p>
             <a:r>
-              <a:rPr kumimoji="0" lang="es-ES" smtClean="0"/>
+              <a:rPr kumimoji="0" lang="es-ES"/>
               <a:t>Haga clic para modificar el estilo de título del patrón</a:t>
             </a:r>
             <a:endParaRPr kumimoji="0" lang="en-US"/>
@@ -464,35 +480,35 @@
           <a:p>
             <a:pPr lvl="0" eaLnBrk="1" latinLnBrk="0" hangingPunct="1"/>
             <a:r>
-              <a:rPr lang="es-ES" smtClean="0"/>
+              <a:rPr lang="es-ES"/>
               <a:t>Haga clic para modificar el estilo de texto del patrón</a:t>
             </a:r>
           </a:p>
           <a:p>
             <a:pPr lvl="1" eaLnBrk="1" latinLnBrk="0" hangingPunct="1"/>
             <a:r>
-              <a:rPr lang="es-ES" smtClean="0"/>
+              <a:rPr lang="es-ES"/>
               <a:t>Segundo nivel</a:t>
             </a:r>
           </a:p>
           <a:p>
             <a:pPr lvl="2" eaLnBrk="1" latinLnBrk="0" hangingPunct="1"/>
             <a:r>
-              <a:rPr lang="es-ES" smtClean="0"/>
+              <a:rPr lang="es-ES"/>
               <a:t>Tercer nivel</a:t>
             </a:r>
           </a:p>
           <a:p>
             <a:pPr lvl="3" eaLnBrk="1" latinLnBrk="0" hangingPunct="1"/>
             <a:r>
-              <a:rPr lang="es-ES" smtClean="0"/>
+              <a:rPr lang="es-ES"/>
               <a:t>Cuarto nivel</a:t>
             </a:r>
           </a:p>
           <a:p>
             <a:pPr lvl="4" eaLnBrk="1" latinLnBrk="0" hangingPunct="1"/>
             <a:r>
-              <a:rPr lang="es-ES" smtClean="0"/>
+              <a:rPr lang="es-ES"/>
               <a:t>Quinto nivel</a:t>
             </a:r>
             <a:endParaRPr kumimoji="0" lang="en-US"/>
@@ -517,7 +533,7 @@
             <a:fld id="{555B466B-AD3F-45F3-90D4-2662B9CB2B5C}" type="datetimeFigureOut">
               <a:rPr lang="es-AR" smtClean="0"/>
               <a:pPr/>
-              <a:t>14/07/2016</a:t>
+              <a:t>17/7/2016</a:t>
             </a:fld>
             <a:endParaRPr lang="es-AR"/>
           </a:p>
@@ -560,7 +576,7 @@
             <a:fld id="{685FA452-4338-48FE-B3D4-91F5EB6D3E85}" type="slidenum">
               <a:rPr lang="es-AR" smtClean="0"/>
               <a:pPr/>
-              <a:t>‹Nº›</a:t>
+              <a:t>‹#›</a:t>
             </a:fld>
             <a:endParaRPr lang="es-AR"/>
           </a:p>
@@ -612,7 +628,7 @@
           <a:lstStyle/>
           <a:p>
             <a:r>
-              <a:rPr kumimoji="0" lang="es-ES" smtClean="0"/>
+              <a:rPr kumimoji="0" lang="es-ES"/>
               <a:t>Haga clic para modificar el estilo de título del patrón</a:t>
             </a:r>
             <a:endParaRPr kumimoji="0" lang="en-US"/>
@@ -641,35 +657,35 @@
           <a:p>
             <a:pPr lvl="0" eaLnBrk="1" latinLnBrk="0" hangingPunct="1"/>
             <a:r>
-              <a:rPr lang="es-ES" smtClean="0"/>
+              <a:rPr lang="es-ES"/>
               <a:t>Haga clic para modificar el estilo de texto del patrón</a:t>
             </a:r>
           </a:p>
           <a:p>
             <a:pPr lvl="1" eaLnBrk="1" latinLnBrk="0" hangingPunct="1"/>
             <a:r>
-              <a:rPr lang="es-ES" smtClean="0"/>
+              <a:rPr lang="es-ES"/>
               <a:t>Segundo nivel</a:t>
             </a:r>
           </a:p>
           <a:p>
             <a:pPr lvl="2" eaLnBrk="1" latinLnBrk="0" hangingPunct="1"/>
             <a:r>
-              <a:rPr lang="es-ES" smtClean="0"/>
+              <a:rPr lang="es-ES"/>
               <a:t>Tercer nivel</a:t>
             </a:r>
           </a:p>
           <a:p>
             <a:pPr lvl="3" eaLnBrk="1" latinLnBrk="0" hangingPunct="1"/>
             <a:r>
-              <a:rPr lang="es-ES" smtClean="0"/>
+              <a:rPr lang="es-ES"/>
               <a:t>Cuarto nivel</a:t>
             </a:r>
           </a:p>
           <a:p>
             <a:pPr lvl="4" eaLnBrk="1" latinLnBrk="0" hangingPunct="1"/>
             <a:r>
-              <a:rPr lang="es-ES" smtClean="0"/>
+              <a:rPr lang="es-ES"/>
               <a:t>Quinto nivel</a:t>
             </a:r>
             <a:endParaRPr kumimoji="0" lang="en-US"/>
@@ -694,7 +710,7 @@
             <a:fld id="{555B466B-AD3F-45F3-90D4-2662B9CB2B5C}" type="datetimeFigureOut">
               <a:rPr lang="es-AR" smtClean="0"/>
               <a:pPr/>
-              <a:t>14/07/2016</a:t>
+              <a:t>17/7/2016</a:t>
             </a:fld>
             <a:endParaRPr lang="es-AR"/>
           </a:p>
@@ -737,7 +753,7 @@
             <a:fld id="{685FA452-4338-48FE-B3D4-91F5EB6D3E85}" type="slidenum">
               <a:rPr lang="es-AR" smtClean="0"/>
               <a:pPr/>
-              <a:t>‹Nº›</a:t>
+              <a:t>‹#›</a:t>
             </a:fld>
             <a:endParaRPr lang="es-AR"/>
           </a:p>
@@ -789,7 +805,7 @@
           <a:lstStyle/>
           <a:p>
             <a:r>
-              <a:rPr kumimoji="0" lang="es-ES" smtClean="0"/>
+              <a:rPr kumimoji="0" lang="es-ES"/>
               <a:t>Haga clic para modificar el estilo de título del patrón</a:t>
             </a:r>
             <a:endParaRPr kumimoji="0" lang="en-US"/>
@@ -818,35 +834,35 @@
           <a:p>
             <a:pPr lvl="0" eaLnBrk="1" latinLnBrk="0" hangingPunct="1"/>
             <a:r>
-              <a:rPr lang="es-ES" smtClean="0"/>
+              <a:rPr lang="es-ES"/>
               <a:t>Haga clic para modificar el estilo de texto del patrón</a:t>
             </a:r>
           </a:p>
           <a:p>
             <a:pPr lvl="1" eaLnBrk="1" latinLnBrk="0" hangingPunct="1"/>
             <a:r>
-              <a:rPr lang="es-ES" smtClean="0"/>
+              <a:rPr lang="es-ES"/>
               <a:t>Segundo nivel</a:t>
             </a:r>
           </a:p>
           <a:p>
             <a:pPr lvl="2" eaLnBrk="1" latinLnBrk="0" hangingPunct="1"/>
             <a:r>
-              <a:rPr lang="es-ES" smtClean="0"/>
+              <a:rPr lang="es-ES"/>
               <a:t>Tercer nivel</a:t>
             </a:r>
           </a:p>
           <a:p>
             <a:pPr lvl="3" eaLnBrk="1" latinLnBrk="0" hangingPunct="1"/>
             <a:r>
-              <a:rPr lang="es-ES" smtClean="0"/>
+              <a:rPr lang="es-ES"/>
               <a:t>Cuarto nivel</a:t>
             </a:r>
           </a:p>
           <a:p>
             <a:pPr lvl="4" eaLnBrk="1" latinLnBrk="0" hangingPunct="1"/>
             <a:r>
-              <a:rPr lang="es-ES" smtClean="0"/>
+              <a:rPr lang="es-ES"/>
               <a:t>Quinto nivel</a:t>
             </a:r>
             <a:endParaRPr kumimoji="0" lang="en-US"/>
@@ -876,7 +892,7 @@
             <a:fld id="{555B466B-AD3F-45F3-90D4-2662B9CB2B5C}" type="datetimeFigureOut">
               <a:rPr lang="es-AR" smtClean="0"/>
               <a:pPr/>
-              <a:t>14/07/2016</a:t>
+              <a:t>17/7/2016</a:t>
             </a:fld>
             <a:endParaRPr lang="es-AR"/>
           </a:p>
@@ -924,7 +940,7 @@
             <a:fld id="{685FA452-4338-48FE-B3D4-91F5EB6D3E85}" type="slidenum">
               <a:rPr lang="es-AR" smtClean="0"/>
               <a:pPr/>
-              <a:t>‹Nº›</a:t>
+              <a:t>‹#›</a:t>
             </a:fld>
             <a:endParaRPr lang="es-AR"/>
           </a:p>
@@ -1125,7 +1141,7 @@
             <a:fld id="{555B466B-AD3F-45F3-90D4-2662B9CB2B5C}" type="datetimeFigureOut">
               <a:rPr lang="es-AR" smtClean="0"/>
               <a:pPr/>
-              <a:t>14/07/2016</a:t>
+              <a:t>17/7/2016</a:t>
             </a:fld>
             <a:endParaRPr lang="es-AR"/>
           </a:p>
@@ -1178,7 +1194,7 @@
             <a:fld id="{685FA452-4338-48FE-B3D4-91F5EB6D3E85}" type="slidenum">
               <a:rPr lang="es-AR" smtClean="0"/>
               <a:pPr/>
-              <a:t>‹Nº›</a:t>
+              <a:t>‹#›</a:t>
             </a:fld>
             <a:endParaRPr lang="es-AR"/>
           </a:p>
@@ -1294,7 +1310,7 @@
           </a:lstStyle>
           <a:p>
             <a:r>
-              <a:rPr kumimoji="0" lang="es-ES" smtClean="0"/>
+              <a:rPr kumimoji="0" lang="es-ES"/>
               <a:t>Haga clic para modificar el estilo de título del patrón</a:t>
             </a:r>
             <a:endParaRPr kumimoji="0" lang="en-US"/>
@@ -1374,7 +1390,7 @@
           <a:p>
             <a:pPr lvl="0" eaLnBrk="1" latinLnBrk="0" hangingPunct="1"/>
             <a:r>
-              <a:rPr kumimoji="0" lang="es-ES" smtClean="0"/>
+              <a:rPr kumimoji="0" lang="es-ES"/>
               <a:t>Haga clic para modificar el estilo de texto del patrón</a:t>
             </a:r>
           </a:p>
@@ -1425,7 +1441,7 @@
           </a:lstStyle>
           <a:p>
             <a:r>
-              <a:rPr kumimoji="0" lang="es-ES" smtClean="0"/>
+              <a:rPr kumimoji="0" lang="es-ES"/>
               <a:t>Haga clic para modificar el estilo de título del patrón</a:t>
             </a:r>
             <a:endParaRPr kumimoji="0" lang="en-US"/>
@@ -1470,35 +1486,35 @@
           <a:p>
             <a:pPr lvl="0" eaLnBrk="1" latinLnBrk="0" hangingPunct="1"/>
             <a:r>
-              <a:rPr lang="es-ES" smtClean="0"/>
+              <a:rPr lang="es-ES"/>
               <a:t>Haga clic para modificar el estilo de texto del patrón</a:t>
             </a:r>
           </a:p>
           <a:p>
             <a:pPr lvl="1" eaLnBrk="1" latinLnBrk="0" hangingPunct="1"/>
             <a:r>
-              <a:rPr lang="es-ES" smtClean="0"/>
+              <a:rPr lang="es-ES"/>
               <a:t>Segundo nivel</a:t>
             </a:r>
           </a:p>
           <a:p>
             <a:pPr lvl="2" eaLnBrk="1" latinLnBrk="0" hangingPunct="1"/>
             <a:r>
-              <a:rPr lang="es-ES" smtClean="0"/>
+              <a:rPr lang="es-ES"/>
               <a:t>Tercer nivel</a:t>
             </a:r>
           </a:p>
           <a:p>
             <a:pPr lvl="3" eaLnBrk="1" latinLnBrk="0" hangingPunct="1"/>
             <a:r>
-              <a:rPr lang="es-ES" smtClean="0"/>
+              <a:rPr lang="es-ES"/>
               <a:t>Cuarto nivel</a:t>
             </a:r>
           </a:p>
           <a:p>
             <a:pPr lvl="4" eaLnBrk="1" latinLnBrk="0" hangingPunct="1"/>
             <a:r>
-              <a:rPr lang="es-ES" smtClean="0"/>
+              <a:rPr lang="es-ES"/>
               <a:t>Quinto nivel</a:t>
             </a:r>
             <a:endParaRPr kumimoji="0" lang="en-US"/>
@@ -1543,35 +1559,35 @@
           <a:p>
             <a:pPr lvl="0" eaLnBrk="1" latinLnBrk="0" hangingPunct="1"/>
             <a:r>
-              <a:rPr lang="es-ES" smtClean="0"/>
+              <a:rPr lang="es-ES"/>
               <a:t>Haga clic para modificar el estilo de texto del patrón</a:t>
             </a:r>
           </a:p>
           <a:p>
             <a:pPr lvl="1" eaLnBrk="1" latinLnBrk="0" hangingPunct="1"/>
             <a:r>
-              <a:rPr lang="es-ES" smtClean="0"/>
+              <a:rPr lang="es-ES"/>
               <a:t>Segundo nivel</a:t>
             </a:r>
           </a:p>
           <a:p>
             <a:pPr lvl="2" eaLnBrk="1" latinLnBrk="0" hangingPunct="1"/>
             <a:r>
-              <a:rPr lang="es-ES" smtClean="0"/>
+              <a:rPr lang="es-ES"/>
               <a:t>Tercer nivel</a:t>
             </a:r>
           </a:p>
           <a:p>
             <a:pPr lvl="3" eaLnBrk="1" latinLnBrk="0" hangingPunct="1"/>
             <a:r>
-              <a:rPr lang="es-ES" smtClean="0"/>
+              <a:rPr lang="es-ES"/>
               <a:t>Cuarto nivel</a:t>
             </a:r>
           </a:p>
           <a:p>
             <a:pPr lvl="4" eaLnBrk="1" latinLnBrk="0" hangingPunct="1"/>
             <a:r>
-              <a:rPr lang="es-ES" smtClean="0"/>
+              <a:rPr lang="es-ES"/>
               <a:t>Quinto nivel</a:t>
             </a:r>
             <a:endParaRPr kumimoji="0" lang="en-US"/>
@@ -1601,7 +1617,7 @@
             <a:fld id="{555B466B-AD3F-45F3-90D4-2662B9CB2B5C}" type="datetimeFigureOut">
               <a:rPr lang="es-AR" smtClean="0"/>
               <a:pPr/>
-              <a:t>14/07/2016</a:t>
+              <a:t>17/7/2016</a:t>
             </a:fld>
             <a:endParaRPr lang="es-AR"/>
           </a:p>
@@ -1654,7 +1670,7 @@
             <a:fld id="{685FA452-4338-48FE-B3D4-91F5EB6D3E85}" type="slidenum">
               <a:rPr lang="es-AR" smtClean="0"/>
               <a:pPr/>
-              <a:t>‹Nº›</a:t>
+              <a:t>‹#›</a:t>
             </a:fld>
             <a:endParaRPr lang="es-AR"/>
           </a:p>
@@ -1724,7 +1740,7 @@
           </a:lstStyle>
           <a:p>
             <a:r>
-              <a:rPr kumimoji="0" lang="es-ES" smtClean="0"/>
+              <a:rPr kumimoji="0" lang="es-ES"/>
               <a:t>Haga clic para modificar el estilo de título del patrón</a:t>
             </a:r>
             <a:endParaRPr kumimoji="0" lang="en-US"/>
@@ -1784,7 +1800,7 @@
           <a:p>
             <a:pPr lvl="0" eaLnBrk="1" latinLnBrk="0" hangingPunct="1"/>
             <a:r>
-              <a:rPr kumimoji="0" lang="es-ES" smtClean="0"/>
+              <a:rPr kumimoji="0" lang="es-ES"/>
               <a:t>Haga clic para modificar el estilo de texto del patrón</a:t>
             </a:r>
           </a:p>
@@ -1843,7 +1859,7 @@
           <a:p>
             <a:pPr lvl="0" eaLnBrk="1" latinLnBrk="0" hangingPunct="1"/>
             <a:r>
-              <a:rPr kumimoji="0" lang="es-ES" smtClean="0"/>
+              <a:rPr kumimoji="0" lang="es-ES"/>
               <a:t>Haga clic para modificar el estilo de texto del patrón</a:t>
             </a:r>
           </a:p>
@@ -1887,35 +1903,35 @@
           <a:p>
             <a:pPr lvl="0" eaLnBrk="1" latinLnBrk="0" hangingPunct="1"/>
             <a:r>
-              <a:rPr lang="es-ES" smtClean="0"/>
+              <a:rPr lang="es-ES"/>
               <a:t>Haga clic para modificar el estilo de texto del patrón</a:t>
             </a:r>
           </a:p>
           <a:p>
             <a:pPr lvl="1" eaLnBrk="1" latinLnBrk="0" hangingPunct="1"/>
             <a:r>
-              <a:rPr lang="es-ES" smtClean="0"/>
+              <a:rPr lang="es-ES"/>
               <a:t>Segundo nivel</a:t>
             </a:r>
           </a:p>
           <a:p>
             <a:pPr lvl="2" eaLnBrk="1" latinLnBrk="0" hangingPunct="1"/>
             <a:r>
-              <a:rPr lang="es-ES" smtClean="0"/>
+              <a:rPr lang="es-ES"/>
               <a:t>Tercer nivel</a:t>
             </a:r>
           </a:p>
           <a:p>
             <a:pPr lvl="3" eaLnBrk="1" latinLnBrk="0" hangingPunct="1"/>
             <a:r>
-              <a:rPr lang="es-ES" smtClean="0"/>
+              <a:rPr lang="es-ES"/>
               <a:t>Cuarto nivel</a:t>
             </a:r>
           </a:p>
           <a:p>
             <a:pPr lvl="4" eaLnBrk="1" latinLnBrk="0" hangingPunct="1"/>
             <a:r>
-              <a:rPr lang="es-ES" smtClean="0"/>
+              <a:rPr lang="es-ES"/>
               <a:t>Quinto nivel</a:t>
             </a:r>
             <a:endParaRPr kumimoji="0" lang="en-US"/>
@@ -1960,35 +1976,35 @@
           <a:p>
             <a:pPr lvl="0" eaLnBrk="1" latinLnBrk="0" hangingPunct="1"/>
             <a:r>
-              <a:rPr lang="es-ES" smtClean="0"/>
+              <a:rPr lang="es-ES"/>
               <a:t>Haga clic para modificar el estilo de texto del patrón</a:t>
             </a:r>
           </a:p>
           <a:p>
             <a:pPr lvl="1" eaLnBrk="1" latinLnBrk="0" hangingPunct="1"/>
             <a:r>
-              <a:rPr lang="es-ES" smtClean="0"/>
+              <a:rPr lang="es-ES"/>
               <a:t>Segundo nivel</a:t>
             </a:r>
           </a:p>
           <a:p>
             <a:pPr lvl="2" eaLnBrk="1" latinLnBrk="0" hangingPunct="1"/>
             <a:r>
-              <a:rPr lang="es-ES" smtClean="0"/>
+              <a:rPr lang="es-ES"/>
               <a:t>Tercer nivel</a:t>
             </a:r>
           </a:p>
           <a:p>
             <a:pPr lvl="3" eaLnBrk="1" latinLnBrk="0" hangingPunct="1"/>
             <a:r>
-              <a:rPr lang="es-ES" smtClean="0"/>
+              <a:rPr lang="es-ES"/>
               <a:t>Cuarto nivel</a:t>
             </a:r>
           </a:p>
           <a:p>
             <a:pPr lvl="4" eaLnBrk="1" latinLnBrk="0" hangingPunct="1"/>
             <a:r>
-              <a:rPr lang="es-ES" smtClean="0"/>
+              <a:rPr lang="es-ES"/>
               <a:t>Quinto nivel</a:t>
             </a:r>
             <a:endParaRPr kumimoji="0" lang="en-US"/>
@@ -2018,7 +2034,7 @@
             <a:fld id="{555B466B-AD3F-45F3-90D4-2662B9CB2B5C}" type="datetimeFigureOut">
               <a:rPr lang="es-AR" smtClean="0"/>
               <a:pPr/>
-              <a:t>14/07/2016</a:t>
+              <a:t>17/7/2016</a:t>
             </a:fld>
             <a:endParaRPr lang="es-AR"/>
           </a:p>
@@ -2075,7 +2091,7 @@
             <a:fld id="{685FA452-4338-48FE-B3D4-91F5EB6D3E85}" type="slidenum">
               <a:rPr lang="es-AR" smtClean="0"/>
               <a:pPr/>
-              <a:t>‹Nº›</a:t>
+              <a:t>‹#›</a:t>
             </a:fld>
             <a:endParaRPr lang="es-AR"/>
           </a:p>
@@ -2126,7 +2142,7 @@
           </a:lstStyle>
           <a:p>
             <a:r>
-              <a:rPr kumimoji="0" lang="es-ES" smtClean="0"/>
+              <a:rPr kumimoji="0" lang="es-ES"/>
               <a:t>Haga clic para modificar el estilo de título del patrón</a:t>
             </a:r>
             <a:endParaRPr kumimoji="0" lang="en-US"/>
@@ -2151,7 +2167,7 @@
             <a:fld id="{555B466B-AD3F-45F3-90D4-2662B9CB2B5C}" type="datetimeFigureOut">
               <a:rPr lang="es-AR" smtClean="0"/>
               <a:pPr/>
-              <a:t>14/07/2016</a:t>
+              <a:t>17/7/2016</a:t>
             </a:fld>
             <a:endParaRPr lang="es-AR"/>
           </a:p>
@@ -2194,7 +2210,7 @@
             <a:fld id="{685FA452-4338-48FE-B3D4-91F5EB6D3E85}" type="slidenum">
               <a:rPr lang="es-AR" smtClean="0"/>
               <a:pPr/>
-              <a:t>‹Nº›</a:t>
+              <a:t>‹#›</a:t>
             </a:fld>
             <a:endParaRPr lang="es-AR"/>
           </a:p>
@@ -2248,7 +2264,7 @@
             <a:fld id="{555B466B-AD3F-45F3-90D4-2662B9CB2B5C}" type="datetimeFigureOut">
               <a:rPr lang="es-AR" smtClean="0"/>
               <a:pPr/>
-              <a:t>14/07/2016</a:t>
+              <a:t>17/7/2016</a:t>
             </a:fld>
             <a:endParaRPr lang="es-AR"/>
           </a:p>
@@ -2301,7 +2317,7 @@
             <a:fld id="{685FA452-4338-48FE-B3D4-91F5EB6D3E85}" type="slidenum">
               <a:rPr lang="es-AR" smtClean="0"/>
               <a:pPr/>
-              <a:t>‹Nº›</a:t>
+              <a:t>‹#›</a:t>
             </a:fld>
             <a:endParaRPr lang="es-AR"/>
           </a:p>
@@ -2366,7 +2382,7 @@
           </a:lstStyle>
           <a:p>
             <a:r>
-              <a:rPr kumimoji="0" lang="es-ES" smtClean="0"/>
+              <a:rPr kumimoji="0" lang="es-ES"/>
               <a:t>Haga clic para modificar el estilo de título del patrón</a:t>
             </a:r>
             <a:endParaRPr kumimoji="0" lang="en-US"/>
@@ -2419,7 +2435,7 @@
           <a:p>
             <a:pPr lvl="0" eaLnBrk="1" latinLnBrk="0" hangingPunct="1"/>
             <a:r>
-              <a:rPr kumimoji="0" lang="es-ES" smtClean="0"/>
+              <a:rPr kumimoji="0" lang="es-ES"/>
               <a:t>Haga clic para modificar el estilo de texto del patrón</a:t>
             </a:r>
           </a:p>
@@ -2466,35 +2482,35 @@
           <a:p>
             <a:pPr lvl="0" eaLnBrk="1" latinLnBrk="0" hangingPunct="1"/>
             <a:r>
-              <a:rPr lang="es-ES" smtClean="0"/>
+              <a:rPr lang="es-ES"/>
               <a:t>Haga clic para modificar el estilo de texto del patrón</a:t>
             </a:r>
           </a:p>
           <a:p>
             <a:pPr lvl="1" eaLnBrk="1" latinLnBrk="0" hangingPunct="1"/>
             <a:r>
-              <a:rPr lang="es-ES" smtClean="0"/>
+              <a:rPr lang="es-ES"/>
               <a:t>Segundo nivel</a:t>
             </a:r>
           </a:p>
           <a:p>
             <a:pPr lvl="2" eaLnBrk="1" latinLnBrk="0" hangingPunct="1"/>
             <a:r>
-              <a:rPr lang="es-ES" smtClean="0"/>
+              <a:rPr lang="es-ES"/>
               <a:t>Tercer nivel</a:t>
             </a:r>
           </a:p>
           <a:p>
             <a:pPr lvl="3" eaLnBrk="1" latinLnBrk="0" hangingPunct="1"/>
             <a:r>
-              <a:rPr lang="es-ES" smtClean="0"/>
+              <a:rPr lang="es-ES"/>
               <a:t>Cuarto nivel</a:t>
             </a:r>
           </a:p>
           <a:p>
             <a:pPr lvl="4" eaLnBrk="1" latinLnBrk="0" hangingPunct="1"/>
             <a:r>
-              <a:rPr lang="es-ES" smtClean="0"/>
+              <a:rPr lang="es-ES"/>
               <a:t>Quinto nivel</a:t>
             </a:r>
             <a:endParaRPr kumimoji="0" lang="en-US"/>
@@ -2528,7 +2544,7 @@
             <a:fld id="{555B466B-AD3F-45F3-90D4-2662B9CB2B5C}" type="datetimeFigureOut">
               <a:rPr lang="es-AR" smtClean="0"/>
               <a:pPr/>
-              <a:t>14/07/2016</a:t>
+              <a:t>17/7/2016</a:t>
             </a:fld>
             <a:endParaRPr lang="es-AR"/>
           </a:p>
@@ -2589,7 +2605,7 @@
             <a:fld id="{685FA452-4338-48FE-B3D4-91F5EB6D3E85}" type="slidenum">
               <a:rPr lang="es-AR" smtClean="0"/>
               <a:pPr/>
-              <a:t>‹Nº›</a:t>
+              <a:t>‹#›</a:t>
             </a:fld>
             <a:endParaRPr lang="es-AR"/>
           </a:p>
@@ -2651,7 +2667,7 @@
           </a:lstStyle>
           <a:p>
             <a:r>
-              <a:rPr kumimoji="0" lang="es-ES" smtClean="0"/>
+              <a:rPr kumimoji="0" lang="es-ES"/>
               <a:t>Haga clic para modificar el estilo de título del patrón</a:t>
             </a:r>
             <a:endParaRPr kumimoji="0" lang="en-US"/>
@@ -2689,7 +2705,7 @@
           </a:lstStyle>
           <a:p>
             <a:r>
-              <a:rPr kumimoji="0" lang="es-ES" smtClean="0"/>
+              <a:rPr kumimoji="0" lang="es-ES"/>
               <a:t>Haga clic en el icono para agregar una imagen</a:t>
             </a:r>
             <a:endParaRPr kumimoji="0" lang="en-US" dirty="0"/>
@@ -2749,7 +2765,7 @@
           <a:p>
             <a:pPr lvl="0" eaLnBrk="1" latinLnBrk="0" hangingPunct="1"/>
             <a:r>
-              <a:rPr kumimoji="0" lang="es-ES" smtClean="0"/>
+              <a:rPr kumimoji="0" lang="es-ES"/>
               <a:t>Haga clic para modificar el estilo de texto del patrón</a:t>
             </a:r>
           </a:p>
@@ -2782,7 +2798,7 @@
             <a:fld id="{555B466B-AD3F-45F3-90D4-2662B9CB2B5C}" type="datetimeFigureOut">
               <a:rPr lang="es-AR" smtClean="0"/>
               <a:pPr/>
-              <a:t>14/07/2016</a:t>
+              <a:t>17/7/2016</a:t>
             </a:fld>
             <a:endParaRPr lang="es-AR"/>
           </a:p>
@@ -2843,7 +2859,7 @@
             <a:fld id="{685FA452-4338-48FE-B3D4-91F5EB6D3E85}" type="slidenum">
               <a:rPr lang="es-AR" smtClean="0"/>
               <a:pPr/>
-              <a:t>‹Nº›</a:t>
+              <a:t>‹#›</a:t>
             </a:fld>
             <a:endParaRPr lang="es-AR"/>
           </a:p>
@@ -3053,7 +3069,7 @@
           <a:lstStyle/>
           <a:p>
             <a:r>
-              <a:rPr kumimoji="0" lang="es-ES" smtClean="0"/>
+              <a:rPr kumimoji="0" lang="es-ES"/>
               <a:t>Haga clic para modificar el estilo de título del patrón</a:t>
             </a:r>
             <a:endParaRPr kumimoji="0" lang="en-US"/>
@@ -3087,35 +3103,35 @@
           <a:p>
             <a:pPr lvl="0" eaLnBrk="1" latinLnBrk="0" hangingPunct="1"/>
             <a:r>
-              <a:rPr kumimoji="0" lang="es-ES" smtClean="0"/>
+              <a:rPr kumimoji="0" lang="es-ES"/>
               <a:t>Haga clic para modificar el estilo de texto del patrón</a:t>
             </a:r>
           </a:p>
           <a:p>
             <a:pPr lvl="1" eaLnBrk="1" latinLnBrk="0" hangingPunct="1"/>
             <a:r>
-              <a:rPr kumimoji="0" lang="es-ES" smtClean="0"/>
+              <a:rPr kumimoji="0" lang="es-ES"/>
               <a:t>Segundo nivel</a:t>
             </a:r>
           </a:p>
           <a:p>
             <a:pPr lvl="2" eaLnBrk="1" latinLnBrk="0" hangingPunct="1"/>
             <a:r>
-              <a:rPr kumimoji="0" lang="es-ES" smtClean="0"/>
+              <a:rPr kumimoji="0" lang="es-ES"/>
               <a:t>Tercer nivel</a:t>
             </a:r>
           </a:p>
           <a:p>
             <a:pPr lvl="3" eaLnBrk="1" latinLnBrk="0" hangingPunct="1"/>
             <a:r>
-              <a:rPr kumimoji="0" lang="es-ES" smtClean="0"/>
+              <a:rPr kumimoji="0" lang="es-ES"/>
               <a:t>Cuarto nivel</a:t>
             </a:r>
           </a:p>
           <a:p>
             <a:pPr lvl="4" eaLnBrk="1" latinLnBrk="0" hangingPunct="1"/>
             <a:r>
-              <a:rPr kumimoji="0" lang="es-ES" smtClean="0"/>
+              <a:rPr kumimoji="0" lang="es-ES"/>
               <a:t>Quinto nivel</a:t>
             </a:r>
             <a:endParaRPr kumimoji="0" lang="en-US"/>
@@ -3156,7 +3172,7 @@
             <a:fld id="{555B466B-AD3F-45F3-90D4-2662B9CB2B5C}" type="datetimeFigureOut">
               <a:rPr lang="es-AR" smtClean="0"/>
               <a:pPr/>
-              <a:t>14/07/2016</a:t>
+              <a:t>17/7/2016</a:t>
             </a:fld>
             <a:endParaRPr lang="es-AR"/>
           </a:p>
@@ -3231,7 +3247,7 @@
             <a:fld id="{685FA452-4338-48FE-B3D4-91F5EB6D3E85}" type="slidenum">
               <a:rPr lang="es-AR" smtClean="0"/>
               <a:pPr/>
-              <a:t>‹Nº›</a:t>
+              <a:t>‹#›</a:t>
             </a:fld>
             <a:endParaRPr lang="es-AR"/>
           </a:p>
@@ -3592,11 +3608,11 @@
           <a:lstStyle/>
           <a:p>
             <a:r>
-              <a:rPr lang="es-AR" dirty="0" smtClean="0"/>
+              <a:rPr lang="es-AR" dirty="0"/>
               <a:t>Proyecto Zeus - </a:t>
             </a:r>
             <a:r>
-              <a:rPr lang="es-AR" dirty="0" err="1" smtClean="0"/>
+              <a:rPr lang="es-AR" dirty="0" err="1"/>
               <a:t>Meteor</a:t>
             </a:r>
             <a:endParaRPr lang="es-AR" dirty="0"/>
@@ -3619,10 +3635,9 @@
           <a:lstStyle/>
           <a:p>
             <a:r>
-              <a:rPr lang="es-AR" dirty="0" smtClean="0"/>
+              <a:rPr lang="es-AR" dirty="0"/>
               <a:t>Sistema de Gestión de Servicios</a:t>
             </a:r>
-            <a:endParaRPr lang="es-AR" dirty="0"/>
           </a:p>
         </p:txBody>
       </p:sp>
@@ -3667,17 +3682,16 @@
           <a:lstStyle/>
           <a:p>
             <a:r>
-              <a:rPr lang="es-AR" dirty="0" smtClean="0"/>
+              <a:rPr lang="es-AR" dirty="0"/>
               <a:t>Principales Estructuras de </a:t>
             </a:r>
             <a:br>
-              <a:rPr lang="es-AR" dirty="0" smtClean="0"/>
+              <a:rPr lang="es-AR" dirty="0"/>
             </a:br>
             <a:r>
-              <a:rPr lang="es-AR" dirty="0" smtClean="0"/>
+              <a:rPr lang="es-AR" dirty="0"/>
               <a:t>Atención de Clientes</a:t>
             </a:r>
-            <a:endParaRPr lang="es-AR" dirty="0"/>
           </a:p>
         </p:txBody>
       </p:sp>
@@ -3718,10 +3732,9 @@
           <a:p>
             <a:pPr algn="ctr"/>
             <a:r>
-              <a:rPr lang="es-AR" dirty="0" smtClean="0"/>
+              <a:rPr lang="es-AR" dirty="0"/>
               <a:t>Cuentas</a:t>
             </a:r>
-            <a:endParaRPr lang="es-AR" dirty="0"/>
           </a:p>
         </p:txBody>
       </p:sp>
@@ -3762,10 +3775,9 @@
           <a:p>
             <a:pPr algn="ctr"/>
             <a:r>
-              <a:rPr lang="es-AR" dirty="0" smtClean="0"/>
+              <a:rPr lang="es-AR" dirty="0"/>
               <a:t>Cliente</a:t>
             </a:r>
-            <a:endParaRPr lang="es-AR" dirty="0"/>
           </a:p>
         </p:txBody>
       </p:sp>
@@ -3806,10 +3818,9 @@
           <a:p>
             <a:pPr algn="ctr"/>
             <a:r>
-              <a:rPr lang="es-AR" dirty="0" smtClean="0"/>
+              <a:rPr lang="es-AR" dirty="0"/>
               <a:t>Contratos</a:t>
             </a:r>
-            <a:endParaRPr lang="es-AR" dirty="0"/>
           </a:p>
         </p:txBody>
       </p:sp>
@@ -3821,7 +3832,7 @@
         </p:nvSpPr>
         <p:spPr>
           <a:xfrm>
-            <a:off x="2843808" y="3573016"/>
+            <a:off x="2843808" y="3501008"/>
             <a:ext cx="1296144" cy="648072"/>
           </a:xfrm>
           <a:prstGeom prst="rect">
@@ -3850,7 +3861,7 @@
           <a:p>
             <a:pPr algn="ctr"/>
             <a:r>
-              <a:rPr lang="es-AR" dirty="0" err="1" smtClean="0"/>
+              <a:rPr lang="es-AR" dirty="0" err="1"/>
               <a:t>Edesals</a:t>
             </a:r>
             <a:endParaRPr lang="es-AR" dirty="0"/>
@@ -3865,7 +3876,7 @@
         </p:nvSpPr>
         <p:spPr>
           <a:xfrm>
-            <a:off x="4427984" y="5013176"/>
+            <a:off x="4427984" y="4941168"/>
             <a:ext cx="1296144" cy="648072"/>
           </a:xfrm>
           <a:prstGeom prst="rect">
@@ -3894,10 +3905,9 @@
           <a:p>
             <a:pPr algn="ctr"/>
             <a:r>
-              <a:rPr lang="es-AR" dirty="0" smtClean="0"/>
+              <a:rPr lang="es-AR" dirty="0"/>
               <a:t>Suministro</a:t>
             </a:r>
-            <a:endParaRPr lang="es-AR" dirty="0"/>
           </a:p>
         </p:txBody>
       </p:sp>
@@ -3909,7 +3919,7 @@
         </p:nvSpPr>
         <p:spPr>
           <a:xfrm>
-            <a:off x="6012160" y="5013176"/>
+            <a:off x="6012160" y="4941168"/>
             <a:ext cx="1296144" cy="648072"/>
           </a:xfrm>
           <a:prstGeom prst="rect">
@@ -3938,7 +3948,7 @@
           <a:p>
             <a:pPr algn="ctr"/>
             <a:r>
-              <a:rPr lang="es-AR" dirty="0" err="1" smtClean="0"/>
+              <a:rPr lang="es-AR" dirty="0" err="1"/>
               <a:t>Medidors</a:t>
             </a:r>
             <a:endParaRPr lang="es-AR" dirty="0"/>
@@ -3953,7 +3963,7 @@
         </p:nvSpPr>
         <p:spPr>
           <a:xfrm>
-            <a:off x="7596336" y="5013176"/>
+            <a:off x="7596336" y="4941168"/>
             <a:ext cx="1296144" cy="648072"/>
           </a:xfrm>
           <a:prstGeom prst="rect">
@@ -3982,10 +3992,9 @@
           <a:p>
             <a:pPr algn="ctr"/>
             <a:r>
-              <a:rPr lang="es-AR" dirty="0" smtClean="0"/>
+              <a:rPr lang="es-AR" dirty="0"/>
               <a:t>Lecturas</a:t>
             </a:r>
-            <a:endParaRPr lang="es-AR" dirty="0"/>
           </a:p>
         </p:txBody>
       </p:sp>
@@ -3997,7 +4006,7 @@
         </p:nvSpPr>
         <p:spPr>
           <a:xfrm>
-            <a:off x="4427984" y="3573016"/>
+            <a:off x="4427984" y="3501008"/>
             <a:ext cx="1296144" cy="648072"/>
           </a:xfrm>
           <a:prstGeom prst="rect">
@@ -4026,10 +4035,9 @@
           <a:p>
             <a:pPr algn="ctr"/>
             <a:r>
-              <a:rPr lang="es-AR" dirty="0" smtClean="0"/>
+              <a:rPr lang="es-AR" dirty="0"/>
               <a:t>Facturas</a:t>
             </a:r>
-            <a:endParaRPr lang="es-AR" dirty="0"/>
           </a:p>
         </p:txBody>
       </p:sp>
@@ -4041,7 +4049,7 @@
         </p:nvSpPr>
         <p:spPr>
           <a:xfrm>
-            <a:off x="6012160" y="3573016"/>
+            <a:off x="6012160" y="3501008"/>
             <a:ext cx="1296144" cy="648072"/>
           </a:xfrm>
           <a:prstGeom prst="rect">
@@ -4070,10 +4078,9 @@
           <a:p>
             <a:pPr algn="ctr"/>
             <a:r>
-              <a:rPr lang="es-AR" dirty="0" smtClean="0"/>
+              <a:rPr lang="es-AR" dirty="0"/>
               <a:t>Líneas</a:t>
             </a:r>
-            <a:endParaRPr lang="es-AR" dirty="0"/>
           </a:p>
         </p:txBody>
       </p:sp>
@@ -4085,7 +4092,7 @@
         </p:nvSpPr>
         <p:spPr>
           <a:xfrm>
-            <a:off x="4427984" y="2852936"/>
+            <a:off x="4427984" y="2780928"/>
             <a:ext cx="1296144" cy="648072"/>
           </a:xfrm>
           <a:prstGeom prst="rect">
@@ -4114,11 +4121,11 @@
           <a:p>
             <a:pPr algn="ctr"/>
             <a:r>
-              <a:rPr lang="es-AR" dirty="0" smtClean="0"/>
+              <a:rPr lang="es-AR" dirty="0"/>
               <a:t>Cargos </a:t>
             </a:r>
             <a:r>
-              <a:rPr lang="es-AR" dirty="0" err="1" smtClean="0"/>
+              <a:rPr lang="es-AR" dirty="0" err="1"/>
               <a:t>Add</a:t>
             </a:r>
             <a:endParaRPr lang="es-AR" dirty="0"/>
@@ -4133,7 +4140,7 @@
         </p:nvSpPr>
         <p:spPr>
           <a:xfrm>
-            <a:off x="6012160" y="5733256"/>
+            <a:off x="6012160" y="5661248"/>
             <a:ext cx="1296144" cy="648072"/>
           </a:xfrm>
           <a:prstGeom prst="rect">
@@ -4162,10 +4169,9 @@
           <a:p>
             <a:pPr algn="ctr"/>
             <a:r>
-              <a:rPr lang="es-AR" dirty="0" smtClean="0"/>
+              <a:rPr lang="es-AR" dirty="0"/>
               <a:t>Os Trabajo</a:t>
             </a:r>
-            <a:endParaRPr lang="es-AR" dirty="0"/>
           </a:p>
         </p:txBody>
       </p:sp>
@@ -4177,7 +4183,7 @@
         </p:nvSpPr>
         <p:spPr>
           <a:xfrm>
-            <a:off x="4427984" y="2132856"/>
+            <a:off x="4427984" y="2060848"/>
             <a:ext cx="1296144" cy="648072"/>
           </a:xfrm>
           <a:prstGeom prst="rect">
@@ -4206,10 +4212,9 @@
           <a:p>
             <a:pPr algn="ctr"/>
             <a:r>
-              <a:rPr lang="es-AR" dirty="0" smtClean="0"/>
+              <a:rPr lang="es-AR" dirty="0"/>
               <a:t>Acuerdos</a:t>
             </a:r>
-            <a:endParaRPr lang="es-AR" dirty="0"/>
           </a:p>
         </p:txBody>
       </p:sp>
@@ -4221,7 +4226,7 @@
         </p:nvSpPr>
         <p:spPr>
           <a:xfrm>
-            <a:off x="4427984" y="4293096"/>
+            <a:off x="4427984" y="4221088"/>
             <a:ext cx="1296144" cy="648072"/>
           </a:xfrm>
           <a:prstGeom prst="rect">
@@ -4250,10 +4255,9 @@
           <a:p>
             <a:pPr algn="ctr"/>
             <a:r>
-              <a:rPr lang="es-AR" dirty="0" smtClean="0"/>
+              <a:rPr lang="es-AR" dirty="0"/>
               <a:t>Reclamos</a:t>
             </a:r>
-            <a:endParaRPr lang="es-AR" dirty="0"/>
           </a:p>
         </p:txBody>
       </p:sp>
@@ -4294,10 +4298,9 @@
           <a:p>
             <a:pPr algn="ctr"/>
             <a:r>
-              <a:rPr lang="es-AR" dirty="0" smtClean="0"/>
+              <a:rPr lang="es-AR" dirty="0"/>
               <a:t>Historial</a:t>
             </a:r>
-            <a:endParaRPr lang="es-AR" dirty="0"/>
           </a:p>
         </p:txBody>
       </p:sp>
@@ -4312,7 +4315,7 @@
         </p:nvCxnSpPr>
         <p:spPr>
           <a:xfrm flipV="1">
-            <a:off x="4139952" y="2456892"/>
+            <a:off x="4139952" y="2384884"/>
             <a:ext cx="288032" cy="1440160"/>
           </a:xfrm>
           <a:prstGeom prst="bentConnector3">
@@ -4347,7 +4350,7 @@
         </p:nvCxnSpPr>
         <p:spPr>
           <a:xfrm flipV="1">
-            <a:off x="4139952" y="3176972"/>
+            <a:off x="4139952" y="3104964"/>
             <a:ext cx="288032" cy="720080"/>
           </a:xfrm>
           <a:prstGeom prst="bentConnector3">
@@ -4382,7 +4385,7 @@
         </p:nvCxnSpPr>
         <p:spPr>
           <a:xfrm>
-            <a:off x="4139952" y="3897052"/>
+            <a:off x="4139952" y="3825044"/>
             <a:ext cx="288032" cy="12700"/>
           </a:xfrm>
           <a:prstGeom prst="bentConnector3">
@@ -4417,7 +4420,7 @@
         </p:nvCxnSpPr>
         <p:spPr>
           <a:xfrm>
-            <a:off x="4139952" y="3897052"/>
+            <a:off x="4139952" y="3825044"/>
             <a:ext cx="288032" cy="720080"/>
           </a:xfrm>
           <a:prstGeom prst="bentConnector3">
@@ -4452,7 +4455,7 @@
         </p:nvCxnSpPr>
         <p:spPr>
           <a:xfrm>
-            <a:off x="4139952" y="3897052"/>
+            <a:off x="4139952" y="3825044"/>
             <a:ext cx="288032" cy="1440160"/>
           </a:xfrm>
           <a:prstGeom prst="bentConnector3">
@@ -4487,7 +4490,7 @@
         </p:nvCxnSpPr>
         <p:spPr>
           <a:xfrm>
-            <a:off x="5724128" y="3897052"/>
+            <a:off x="5724128" y="3825044"/>
             <a:ext cx="288032" cy="12700"/>
           </a:xfrm>
           <a:prstGeom prst="bentConnector3">
@@ -4522,7 +4525,7 @@
         </p:nvCxnSpPr>
         <p:spPr>
           <a:xfrm>
-            <a:off x="5724128" y="5337212"/>
+            <a:off x="5724128" y="5265204"/>
             <a:ext cx="288032" cy="12700"/>
           </a:xfrm>
           <a:prstGeom prst="bentConnector3">
@@ -4557,7 +4560,7 @@
         </p:nvCxnSpPr>
         <p:spPr>
           <a:xfrm>
-            <a:off x="5724128" y="5337212"/>
+            <a:off x="5724128" y="5265204"/>
             <a:ext cx="288032" cy="720080"/>
           </a:xfrm>
           <a:prstGeom prst="bentConnector3">
@@ -4592,7 +4595,7 @@
         </p:nvCxnSpPr>
         <p:spPr>
           <a:xfrm>
-            <a:off x="7308304" y="5337212"/>
+            <a:off x="7308304" y="5265204"/>
             <a:ext cx="288032" cy="12700"/>
           </a:xfrm>
           <a:prstGeom prst="bentConnector3">
@@ -4727,7 +4730,7 @@
         <p:spPr>
           <a:xfrm>
             <a:off x="1619672" y="3825044"/>
-            <a:ext cx="1224136" cy="72008"/>
+            <a:ext cx="1224136" cy="0"/>
           </a:xfrm>
           <a:prstGeom prst="line">
             <a:avLst/>

</xml_diff>